<commit_message>
Update test with column-related styles.
</commit_message>
<xml_diff>
--- a/test-data/slideshow/table-with-different-font-colors.pptx
+++ b/test-data/slideshow/table-with-different-font-colors.pptx
@@ -5,7 +5,8 @@
     <p:sldMasterId id="2147483648" r:id="rId1"/>
   </p:sldMasterIdLst>
   <p:sldIdLst>
-    <p:sldId id="256" r:id="rId2"/>
+    <p:sldId id="257" r:id="rId2"/>
+    <p:sldId id="258" r:id="rId3"/>
   </p:sldIdLst>
   <p:sldSz cx="12192000" cy="6858000"/>
   <p:notesSz cx="6858000" cy="9144000"/>
@@ -116,25 +117,47 @@
 <pc:chgInfo xmlns:a="http://schemas.openxmlformats.org/drawingml/2006/main" xmlns:ac="http://schemas.microsoft.com/office/drawing/2013/main/command" xmlns:pc="http://schemas.microsoft.com/office/powerpoint/2013/main/command" xmlns:r="http://schemas.openxmlformats.org/officeDocument/2006/relationships">
   <pc:docChgLst>
     <pc:chgData clId="{34649501-E0D8-4E62-87E5-6CFBE5BBCA28}" name="Perez, Jacobo" providerId="ADAL" userId="7a138f2c-86a8-4017-9d3c-78443332819b"/>
-    <pc:docChg chg="modSld">
-      <pc:chgData actId="20577" clId="{34649501-E0D8-4E62-87E5-6CFBE5BBCA28}" dt="2025-12-09T06:18:53.576" name="Perez, Jacobo" providerId="ADAL" userId="7a138f2c-86a8-4017-9d3c-78443332819b" v="29"/>
+    <pc:docChg chg="custSel addSld delSld modSld">
+      <pc:chgData actId="207" clId="{34649501-E0D8-4E62-87E5-6CFBE5BBCA28}" dt="2025-12-10T11:37:05.652" name="Perez, Jacobo" providerId="ADAL" userId="7a138f2c-86a8-4017-9d3c-78443332819b" v="167"/>
       <pc:docMkLst>
         <pc:docMk/>
       </pc:docMkLst>
-      <pc:sldChg chg="modSp mod">
-        <pc:chgData actId="20577" clId="{34649501-E0D8-4E62-87E5-6CFBE5BBCA28}" dt="2025-12-09T06:18:53.576" name="Perez, Jacobo" providerId="ADAL" userId="7a138f2c-86a8-4017-9d3c-78443332819b" v="29"/>
+      <pc:sldChg chg="modSp del mod">
+        <pc:chgData actId="47" clId="{34649501-E0D8-4E62-87E5-6CFBE5BBCA28}" dt="2025-12-10T11:35:59.851" name="Perez, Jacobo" providerId="ADAL" userId="7a138f2c-86a8-4017-9d3c-78443332819b" v="162"/>
         <pc:sldMkLst>
           <pc:docMk/>
           <pc:sldMk cId="4185553753" sldId="256"/>
         </pc:sldMkLst>
         <pc:graphicFrameChg chg="modGraphic">
-          <ac:chgData actId="20577" clId="{34649501-E0D8-4E62-87E5-6CFBE5BBCA28}" dt="2025-12-09T06:18:53.576" name="Perez, Jacobo" providerId="ADAL" userId="7a138f2c-86a8-4017-9d3c-78443332819b" v="29"/>
+          <ac:chgData actId="20577" clId="{34649501-E0D8-4E62-87E5-6CFBE5BBCA28}" dt="2025-12-10T11:33:43.300" name="Perez, Jacobo" providerId="ADAL" userId="7a138f2c-86a8-4017-9d3c-78443332819b" v="91"/>
           <ac:graphicFrameMkLst>
             <pc:docMk/>
             <pc:sldMk cId="4185553753" sldId="256"/>
             <ac:graphicFrameMk creationId="{FEF7BBED-19AC-9804-F533-7E72B400CF48}" id="4"/>
           </ac:graphicFrameMkLst>
         </pc:graphicFrameChg>
+      </pc:sldChg>
+      <pc:sldChg chg="modSp add mod">
+        <pc:chgData actId="207" clId="{34649501-E0D8-4E62-87E5-6CFBE5BBCA28}" dt="2025-12-10T11:37:05.652" name="Perez, Jacobo" providerId="ADAL" userId="7a138f2c-86a8-4017-9d3c-78443332819b" v="167"/>
+        <pc:sldMkLst>
+          <pc:docMk/>
+          <pc:sldMk cId="1433262223" sldId="257"/>
+        </pc:sldMkLst>
+        <pc:graphicFrameChg chg="modGraphic">
+          <ac:chgData actId="207" clId="{34649501-E0D8-4E62-87E5-6CFBE5BBCA28}" dt="2025-12-10T11:37:05.652" name="Perez, Jacobo" providerId="ADAL" userId="7a138f2c-86a8-4017-9d3c-78443332819b" v="167"/>
+          <ac:graphicFrameMkLst>
+            <pc:docMk/>
+            <pc:sldMk cId="1433262223" sldId="257"/>
+            <ac:graphicFrameMk creationId="{67C9F8CE-8DF7-B60F-52AF-734216819E97}" id="4"/>
+          </ac:graphicFrameMkLst>
+        </pc:graphicFrameChg>
+      </pc:sldChg>
+      <pc:sldChg chg="add">
+        <pc:chgData actId="2890" clId="{34649501-E0D8-4E62-87E5-6CFBE5BBCA28}" dt="2025-12-10T11:36:00.987" name="Perez, Jacobo" providerId="ADAL" userId="7a138f2c-86a8-4017-9d3c-78443332819b" v="163"/>
+        <pc:sldMkLst>
+          <pc:docMk/>
+          <pc:sldMk cId="1601241158" sldId="258"/>
+        </pc:sldMkLst>
       </pc:sldChg>
     </pc:docChg>
   </pc:docChgLst>
@@ -288,7 +311,7 @@
           <a:p>
             <a:fld id="{F4BE7722-A82B-452B-8BD6-0B16472CEC9A}" type="datetimeFigureOut">
               <a:rPr lang="en-US" smtClean="0"/>
-              <a:t>12/9/2025</a:t>
+              <a:t>12/10/2025</a:t>
             </a:fld>
             <a:endParaRPr lang="en-US"/>
           </a:p>
@@ -486,7 +509,7 @@
           <a:p>
             <a:fld id="{F4BE7722-A82B-452B-8BD6-0B16472CEC9A}" type="datetimeFigureOut">
               <a:rPr lang="en-US" smtClean="0"/>
-              <a:t>12/9/2025</a:t>
+              <a:t>12/10/2025</a:t>
             </a:fld>
             <a:endParaRPr lang="en-US"/>
           </a:p>
@@ -694,7 +717,7 @@
           <a:p>
             <a:fld id="{F4BE7722-A82B-452B-8BD6-0B16472CEC9A}" type="datetimeFigureOut">
               <a:rPr lang="en-US" smtClean="0"/>
-              <a:t>12/9/2025</a:t>
+              <a:t>12/10/2025</a:t>
             </a:fld>
             <a:endParaRPr lang="en-US"/>
           </a:p>
@@ -892,7 +915,7 @@
           <a:p>
             <a:fld id="{F4BE7722-A82B-452B-8BD6-0B16472CEC9A}" type="datetimeFigureOut">
               <a:rPr lang="en-US" smtClean="0"/>
-              <a:t>12/9/2025</a:t>
+              <a:t>12/10/2025</a:t>
             </a:fld>
             <a:endParaRPr lang="en-US"/>
           </a:p>
@@ -1167,7 +1190,7 @@
           <a:p>
             <a:fld id="{F4BE7722-A82B-452B-8BD6-0B16472CEC9A}" type="datetimeFigureOut">
               <a:rPr lang="en-US" smtClean="0"/>
-              <a:t>12/9/2025</a:t>
+              <a:t>12/10/2025</a:t>
             </a:fld>
             <a:endParaRPr lang="en-US"/>
           </a:p>
@@ -1432,7 +1455,7 @@
           <a:p>
             <a:fld id="{F4BE7722-A82B-452B-8BD6-0B16472CEC9A}" type="datetimeFigureOut">
               <a:rPr lang="en-US" smtClean="0"/>
-              <a:t>12/9/2025</a:t>
+              <a:t>12/10/2025</a:t>
             </a:fld>
             <a:endParaRPr lang="en-US"/>
           </a:p>
@@ -1844,7 +1867,7 @@
           <a:p>
             <a:fld id="{F4BE7722-A82B-452B-8BD6-0B16472CEC9A}" type="datetimeFigureOut">
               <a:rPr lang="en-US" smtClean="0"/>
-              <a:t>12/9/2025</a:t>
+              <a:t>12/10/2025</a:t>
             </a:fld>
             <a:endParaRPr lang="en-US"/>
           </a:p>
@@ -1985,7 +2008,7 @@
           <a:p>
             <a:fld id="{F4BE7722-A82B-452B-8BD6-0B16472CEC9A}" type="datetimeFigureOut">
               <a:rPr lang="en-US" smtClean="0"/>
-              <a:t>12/9/2025</a:t>
+              <a:t>12/10/2025</a:t>
             </a:fld>
             <a:endParaRPr lang="en-US"/>
           </a:p>
@@ -2098,7 +2121,7 @@
           <a:p>
             <a:fld id="{F4BE7722-A82B-452B-8BD6-0B16472CEC9A}" type="datetimeFigureOut">
               <a:rPr lang="en-US" smtClean="0"/>
-              <a:t>12/9/2025</a:t>
+              <a:t>12/10/2025</a:t>
             </a:fld>
             <a:endParaRPr lang="en-US"/>
           </a:p>
@@ -2409,7 +2432,7 @@
           <a:p>
             <a:fld id="{F4BE7722-A82B-452B-8BD6-0B16472CEC9A}" type="datetimeFigureOut">
               <a:rPr lang="en-US" smtClean="0"/>
-              <a:t>12/9/2025</a:t>
+              <a:t>12/10/2025</a:t>
             </a:fld>
             <a:endParaRPr lang="en-US"/>
           </a:p>
@@ -2697,7 +2720,7 @@
           <a:p>
             <a:fld id="{F4BE7722-A82B-452B-8BD6-0B16472CEC9A}" type="datetimeFigureOut">
               <a:rPr lang="en-US" smtClean="0"/>
-              <a:t>12/9/2025</a:t>
+              <a:t>12/10/2025</a:t>
             </a:fld>
             <a:endParaRPr lang="en-US"/>
           </a:p>
@@ -2938,7 +2961,7 @@
           <a:p>
             <a:fld id="{F4BE7722-A82B-452B-8BD6-0B16472CEC9A}" type="datetimeFigureOut">
               <a:rPr lang="en-US" smtClean="0"/>
-              <a:t>12/9/2025</a:t>
+              <a:t>12/10/2025</a:t>
             </a:fld>
             <a:endParaRPr lang="en-US"/>
           </a:p>
@@ -3343,7 +3366,13 @@
   <p:cSld>
     <p:spTree>
       <p:nvGrpSpPr>
-        <p:cNvPr id="1" name=""/>
+        <p:cNvPr id="1" name="">
+          <a:extLst>
+            <a:ext uri="{FF2B5EF4-FFF2-40B4-BE49-F238E27FC236}">
+              <a16:creationId xmlns:a16="http://schemas.microsoft.com/office/drawing/2014/main" id="{BDC1C36D-579F-6AC9-83AA-4A2ECAEEF445}"/>
+            </a:ext>
+          </a:extLst>
+        </p:cNvPr>
         <p:cNvGrpSpPr/>
         <p:nvPr/>
       </p:nvGrpSpPr>
@@ -3360,7 +3389,7 @@
           <p:cNvPr id="4" name="Table 3">
             <a:extLst>
               <a:ext uri="{FF2B5EF4-FFF2-40B4-BE49-F238E27FC236}">
-                <a16:creationId xmlns:a16="http://schemas.microsoft.com/office/drawing/2014/main" id="{FEF7BBED-19AC-9804-F533-7E72B400CF48}"/>
+                <a16:creationId xmlns:a16="http://schemas.microsoft.com/office/drawing/2014/main" id="{67C9F8CE-8DF7-B60F-52AF-734216819E97}"/>
               </a:ext>
             </a:extLst>
           </p:cNvPr>
@@ -3370,33 +3399,47 @@
           <p:nvPr>
             <p:extLst>
               <p:ext uri="{D42A27DB-BD31-4B8C-83A1-F6EECF244321}">
-                <p14:modId xmlns:p14="http://schemas.microsoft.com/office/powerpoint/2010/main" val="1344513577"/>
+                <p14:modId xmlns:p14="http://schemas.microsoft.com/office/powerpoint/2010/main" val="3076684137"/>
               </p:ext>
             </p:extLst>
           </p:nvPr>
         </p:nvGraphicFramePr>
         <p:xfrm>
           <a:off x="2032000" y="719666"/>
-          <a:ext cx="8128000" cy="1112520"/>
+          <a:ext cx="8128000" cy="1483360"/>
         </p:xfrm>
         <a:graphic>
           <a:graphicData uri="http://schemas.openxmlformats.org/drawingml/2006/table">
             <a:tbl>
-              <a:tblPr bandRow="1" firstRow="1">
+              <a:tblPr bandRow="1" firstRow="1" lastRow="1">
                 <a:tableStyleId>{5C22544A-7EE6-4342-B048-85BDC9FD1C3A}</a:tableStyleId>
               </a:tblPr>
               <a:tblGrid>
-                <a:gridCol w="4064000">
+                <a:gridCol w="2032000">
                   <a:extLst>
                     <a:ext uri="{9D8B030D-6E8A-4147-A177-3AD203B41FA5}">
                       <a16:colId xmlns:a16="http://schemas.microsoft.com/office/drawing/2014/main" val="2759599280"/>
                     </a:ext>
                   </a:extLst>
                 </a:gridCol>
-                <a:gridCol w="4064000">
+                <a:gridCol w="2032000">
                   <a:extLst>
                     <a:ext uri="{9D8B030D-6E8A-4147-A177-3AD203B41FA5}">
                       <a16:colId xmlns:a16="http://schemas.microsoft.com/office/drawing/2014/main" val="1379972863"/>
+                    </a:ext>
+                  </a:extLst>
+                </a:gridCol>
+                <a:gridCol w="2032000">
+                  <a:extLst>
+                    <a:ext uri="{9D8B030D-6E8A-4147-A177-3AD203B41FA5}">
+                      <a16:colId xmlns:a16="http://schemas.microsoft.com/office/drawing/2014/main" val="405525934"/>
+                    </a:ext>
+                  </a:extLst>
+                </a:gridCol>
+                <a:gridCol w="2032000">
+                  <a:extLst>
+                    <a:ext uri="{9D8B030D-6E8A-4147-A177-3AD203B41FA5}">
+                      <a16:colId xmlns:a16="http://schemas.microsoft.com/office/drawing/2014/main" val="1182572184"/>
                     </a:ext>
                   </a:extLst>
                 </a:gridCol>
@@ -3428,6 +3471,36 @@
                   </a:txBody>
                   <a:tcPr/>
                 </a:tc>
+                <a:tc>
+                  <a:txBody>
+                    <a:bodyPr/>
+                    <a:lstStyle/>
+                    <a:p>
+                      <a:r>
+                        <a:rPr b="0" dirty="0" lang="en-US">
+                          <a:solidFill>
+                            <a:srgbClr val="00B050"/>
+                          </a:solidFill>
+                        </a:rPr>
+                        <a:t>Text 3</a:t>
+                      </a:r>
+                    </a:p>
+                  </a:txBody>
+                  <a:tcPr/>
+                </a:tc>
+                <a:tc>
+                  <a:txBody>
+                    <a:bodyPr/>
+                    <a:lstStyle/>
+                    <a:p>
+                      <a:r>
+                        <a:rPr dirty="0" lang="en-US"/>
+                        <a:t>Text 4</a:t>
+                      </a:r>
+                    </a:p>
+                  </a:txBody>
+                  <a:tcPr/>
+                </a:tc>
                 <a:extLst>
                   <a:ext uri="{0D108BD9-81ED-4DB2-BD59-A6C34878D82A}">
                     <a16:rowId xmlns:a16="http://schemas.microsoft.com/office/drawing/2014/main" val="626625689"/>
@@ -3435,6 +3508,307 @@
                 </a:extLst>
               </a:tr>
               <a:tr h="370840">
+                <a:tc>
+                  <a:txBody>
+                    <a:bodyPr/>
+                    <a:lstStyle/>
+                    <a:p>
+                      <a:r>
+                        <a:rPr dirty="0" lang="en-US"/>
+                        <a:t>Text 5</a:t>
+                      </a:r>
+                    </a:p>
+                  </a:txBody>
+                  <a:tcPr/>
+                </a:tc>
+                <a:tc>
+                  <a:txBody>
+                    <a:bodyPr/>
+                    <a:lstStyle/>
+                    <a:p>
+                      <a:r>
+                        <a:rPr dirty="0" lang="en-US"/>
+                        <a:t>Text 6</a:t>
+                      </a:r>
+                    </a:p>
+                  </a:txBody>
+                  <a:tcPr/>
+                </a:tc>
+                <a:tc>
+                  <a:txBody>
+                    <a:bodyPr/>
+                    <a:lstStyle/>
+                    <a:p>
+                      <a:r>
+                        <a:rPr dirty="0" lang="en-US"/>
+                        <a:t>Text 7</a:t>
+                      </a:r>
+                    </a:p>
+                  </a:txBody>
+                  <a:tcPr/>
+                </a:tc>
+                <a:tc>
+                  <a:txBody>
+                    <a:bodyPr/>
+                    <a:lstStyle/>
+                    <a:p>
+                      <a:r>
+                        <a:rPr dirty="0" lang="en-US"/>
+                        <a:t>Text 8</a:t>
+                      </a:r>
+                    </a:p>
+                  </a:txBody>
+                  <a:tcPr/>
+                </a:tc>
+                <a:extLst>
+                  <a:ext uri="{0D108BD9-81ED-4DB2-BD59-A6C34878D82A}">
+                    <a16:rowId xmlns:a16="http://schemas.microsoft.com/office/drawing/2014/main" val="2504742905"/>
+                  </a:ext>
+                </a:extLst>
+              </a:tr>
+              <a:tr h="370840">
+                <a:tc>
+                  <a:txBody>
+                    <a:bodyPr/>
+                    <a:lstStyle/>
+                    <a:p>
+                      <a:r>
+                        <a:rPr dirty="0" lang="en-US"/>
+                        <a:t>Text 9</a:t>
+                      </a:r>
+                    </a:p>
+                  </a:txBody>
+                  <a:tcPr/>
+                </a:tc>
+                <a:tc>
+                  <a:txBody>
+                    <a:bodyPr/>
+                    <a:lstStyle/>
+                    <a:p>
+                      <a:r>
+                        <a:rPr dirty="0" lang="en-US"/>
+                        <a:t>Text 10</a:t>
+                      </a:r>
+                    </a:p>
+                  </a:txBody>
+                  <a:tcPr/>
+                </a:tc>
+                <a:tc>
+                  <a:txBody>
+                    <a:bodyPr/>
+                    <a:lstStyle/>
+                    <a:p>
+                      <a:r>
+                        <a:rPr dirty="0" i="1" lang="en-US">
+                          <a:solidFill>
+                            <a:srgbClr val="FF0000"/>
+                          </a:solidFill>
+                        </a:rPr>
+                        <a:t>Text 11</a:t>
+                      </a:r>
+                    </a:p>
+                  </a:txBody>
+                  <a:tcPr/>
+                </a:tc>
+                <a:tc>
+                  <a:txBody>
+                    <a:bodyPr/>
+                    <a:lstStyle/>
+                    <a:p>
+                      <a:r>
+                        <a:rPr dirty="0" lang="en-US"/>
+                        <a:t>Text 12</a:t>
+                      </a:r>
+                    </a:p>
+                  </a:txBody>
+                  <a:tcPr/>
+                </a:tc>
+                <a:extLst>
+                  <a:ext uri="{0D108BD9-81ED-4DB2-BD59-A6C34878D82A}">
+                    <a16:rowId xmlns:a16="http://schemas.microsoft.com/office/drawing/2014/main" val="2832339126"/>
+                  </a:ext>
+                </a:extLst>
+              </a:tr>
+              <a:tr h="370840">
+                <a:tc>
+                  <a:txBody>
+                    <a:bodyPr/>
+                    <a:lstStyle/>
+                    <a:p>
+                      <a:r>
+                        <a:rPr dirty="0" lang="en-US"/>
+                        <a:t>Text 13</a:t>
+                      </a:r>
+                    </a:p>
+                  </a:txBody>
+                  <a:tcPr/>
+                </a:tc>
+                <a:tc>
+                  <a:txBody>
+                    <a:bodyPr/>
+                    <a:lstStyle/>
+                    <a:p>
+                      <a:r>
+                        <a:rPr dirty="0" lang="en-US"/>
+                        <a:t>Text 14</a:t>
+                      </a:r>
+                    </a:p>
+                  </a:txBody>
+                  <a:tcPr/>
+                </a:tc>
+                <a:tc>
+                  <a:txBody>
+                    <a:bodyPr/>
+                    <a:lstStyle/>
+                    <a:p>
+                      <a:r>
+                        <a:rPr dirty="0" lang="en-US"/>
+                        <a:t>Text 15</a:t>
+                      </a:r>
+                    </a:p>
+                  </a:txBody>
+                  <a:tcPr/>
+                </a:tc>
+                <a:tc>
+                  <a:txBody>
+                    <a:bodyPr/>
+                    <a:lstStyle/>
+                    <a:p>
+                      <a:r>
+                        <a:rPr dirty="0" lang="en-US"/>
+                        <a:t>Text 16</a:t>
+                      </a:r>
+                    </a:p>
+                  </a:txBody>
+                  <a:tcPr/>
+                </a:tc>
+                <a:extLst>
+                  <a:ext uri="{0D108BD9-81ED-4DB2-BD59-A6C34878D82A}">
+                    <a16:rowId xmlns:a16="http://schemas.microsoft.com/office/drawing/2014/main" val="1995051742"/>
+                  </a:ext>
+                </a:extLst>
+              </a:tr>
+            </a:tbl>
+          </a:graphicData>
+        </a:graphic>
+      </p:graphicFrame>
+    </p:spTree>
+    <p:extLst>
+      <p:ext uri="{BB962C8B-B14F-4D97-AF65-F5344CB8AC3E}">
+        <p14:creationId xmlns:p14="http://schemas.microsoft.com/office/powerpoint/2010/main" val="1433262223"/>
+      </p:ext>
+    </p:extLst>
+  </p:cSld>
+  <p:clrMapOvr>
+    <a:masterClrMapping/>
+  </p:clrMapOvr>
+</p:sld>
+</file>
+
+<file path=ppt/slides/slide2.xml><?xml version="1.0" encoding="utf-8"?>
+<p:sld xmlns:a="http://schemas.openxmlformats.org/drawingml/2006/main" xmlns:p="http://schemas.openxmlformats.org/presentationml/2006/main" xmlns:r="http://schemas.openxmlformats.org/officeDocument/2006/relationships">
+  <p:cSld>
+    <p:spTree>
+      <p:nvGrpSpPr>
+        <p:cNvPr id="1" name="">
+          <a:extLst>
+            <a:ext uri="{FF2B5EF4-FFF2-40B4-BE49-F238E27FC236}">
+              <a16:creationId xmlns:a16="http://schemas.microsoft.com/office/drawing/2014/main" id="{08435446-7E3B-1A74-C738-57EA4E5D48D2}"/>
+            </a:ext>
+          </a:extLst>
+        </p:cNvPr>
+        <p:cNvGrpSpPr/>
+        <p:nvPr/>
+      </p:nvGrpSpPr>
+      <p:grpSpPr>
+        <a:xfrm>
+          <a:off x="0" y="0"/>
+          <a:ext cx="0" cy="0"/>
+          <a:chOff x="0" y="0"/>
+          <a:chExt cx="0" cy="0"/>
+        </a:xfrm>
+      </p:grpSpPr>
+      <p:graphicFrame>
+        <p:nvGraphicFramePr>
+          <p:cNvPr id="4" name="Table 3">
+            <a:extLst>
+              <a:ext uri="{FF2B5EF4-FFF2-40B4-BE49-F238E27FC236}">
+                <a16:creationId xmlns:a16="http://schemas.microsoft.com/office/drawing/2014/main" id="{7BB416EF-1659-3D96-E1C1-DF6CCBFC5855}"/>
+              </a:ext>
+            </a:extLst>
+          </p:cNvPr>
+          <p:cNvGraphicFramePr>
+            <a:graphicFrameLocks noGrp="1"/>
+          </p:cNvGraphicFramePr>
+          <p:nvPr/>
+        </p:nvGraphicFramePr>
+        <p:xfrm>
+          <a:off x="2032000" y="719666"/>
+          <a:ext cx="8128000" cy="1483360"/>
+        </p:xfrm>
+        <a:graphic>
+          <a:graphicData uri="http://schemas.openxmlformats.org/drawingml/2006/table">
+            <a:tbl>
+              <a:tblPr bandCol="1" firstCol="1" lastCol="1">
+                <a:tableStyleId>{5C22544A-7EE6-4342-B048-85BDC9FD1C3A}</a:tableStyleId>
+              </a:tblPr>
+              <a:tblGrid>
+                <a:gridCol w="2032000">
+                  <a:extLst>
+                    <a:ext uri="{9D8B030D-6E8A-4147-A177-3AD203B41FA5}">
+                      <a16:colId xmlns:a16="http://schemas.microsoft.com/office/drawing/2014/main" val="2759599280"/>
+                    </a:ext>
+                  </a:extLst>
+                </a:gridCol>
+                <a:gridCol w="2032000">
+                  <a:extLst>
+                    <a:ext uri="{9D8B030D-6E8A-4147-A177-3AD203B41FA5}">
+                      <a16:colId xmlns:a16="http://schemas.microsoft.com/office/drawing/2014/main" val="1379972863"/>
+                    </a:ext>
+                  </a:extLst>
+                </a:gridCol>
+                <a:gridCol w="2032000">
+                  <a:extLst>
+                    <a:ext uri="{9D8B030D-6E8A-4147-A177-3AD203B41FA5}">
+                      <a16:colId xmlns:a16="http://schemas.microsoft.com/office/drawing/2014/main" val="405525934"/>
+                    </a:ext>
+                  </a:extLst>
+                </a:gridCol>
+                <a:gridCol w="2032000">
+                  <a:extLst>
+                    <a:ext uri="{9D8B030D-6E8A-4147-A177-3AD203B41FA5}">
+                      <a16:colId xmlns:a16="http://schemas.microsoft.com/office/drawing/2014/main" val="1182572184"/>
+                    </a:ext>
+                  </a:extLst>
+                </a:gridCol>
+              </a:tblGrid>
+              <a:tr h="370840">
+                <a:tc>
+                  <a:txBody>
+                    <a:bodyPr/>
+                    <a:lstStyle/>
+                    <a:p>
+                      <a:r>
+                        <a:rPr dirty="0" lang="en-US"/>
+                        <a:t>Text 1</a:t>
+                      </a:r>
+                    </a:p>
+                  </a:txBody>
+                  <a:tcPr/>
+                </a:tc>
+                <a:tc>
+                  <a:txBody>
+                    <a:bodyPr/>
+                    <a:lstStyle/>
+                    <a:p>
+                      <a:r>
+                        <a:rPr dirty="0" lang="en-US"/>
+                        <a:t>Text 2</a:t>
+                      </a:r>
+                    </a:p>
+                  </a:txBody>
+                  <a:tcPr/>
+                </a:tc>
                 <a:tc>
                   <a:txBody>
                     <a:bodyPr/>
@@ -3463,7 +3837,7 @@
                 </a:tc>
                 <a:extLst>
                   <a:ext uri="{0D108BD9-81ED-4DB2-BD59-A6C34878D82A}">
-                    <a16:rowId xmlns:a16="http://schemas.microsoft.com/office/drawing/2014/main" val="2504742905"/>
+                    <a16:rowId xmlns:a16="http://schemas.microsoft.com/office/drawing/2014/main" val="626625689"/>
                   </a:ext>
                 </a:extLst>
               </a:tr>
@@ -3487,10 +3861,94 @@
                     <a:lstStyle/>
                     <a:p>
                       <a:r>
-                        <a:rPr lang="en-US"/>
+                        <a:rPr dirty="0" lang="en-US"/>
                         <a:t>Text 6</a:t>
                       </a:r>
-                      <a:endParaRPr dirty="0" lang="en-US"/>
+                    </a:p>
+                  </a:txBody>
+                  <a:tcPr/>
+                </a:tc>
+                <a:tc>
+                  <a:txBody>
+                    <a:bodyPr/>
+                    <a:lstStyle/>
+                    <a:p>
+                      <a:r>
+                        <a:rPr dirty="0" lang="en-US"/>
+                        <a:t>Text 7</a:t>
+                      </a:r>
+                    </a:p>
+                  </a:txBody>
+                  <a:tcPr/>
+                </a:tc>
+                <a:tc>
+                  <a:txBody>
+                    <a:bodyPr/>
+                    <a:lstStyle/>
+                    <a:p>
+                      <a:r>
+                        <a:rPr dirty="0" lang="en-US"/>
+                        <a:t>Text 8</a:t>
+                      </a:r>
+                    </a:p>
+                  </a:txBody>
+                  <a:tcPr/>
+                </a:tc>
+                <a:extLst>
+                  <a:ext uri="{0D108BD9-81ED-4DB2-BD59-A6C34878D82A}">
+                    <a16:rowId xmlns:a16="http://schemas.microsoft.com/office/drawing/2014/main" val="2504742905"/>
+                  </a:ext>
+                </a:extLst>
+              </a:tr>
+              <a:tr h="370840">
+                <a:tc>
+                  <a:txBody>
+                    <a:bodyPr/>
+                    <a:lstStyle/>
+                    <a:p>
+                      <a:r>
+                        <a:rPr dirty="0" lang="en-US"/>
+                        <a:t>Text 9</a:t>
+                      </a:r>
+                    </a:p>
+                  </a:txBody>
+                  <a:tcPr/>
+                </a:tc>
+                <a:tc>
+                  <a:txBody>
+                    <a:bodyPr/>
+                    <a:lstStyle/>
+                    <a:p>
+                      <a:r>
+                        <a:rPr dirty="0" lang="en-US"/>
+                        <a:t>Text 10</a:t>
+                      </a:r>
+                    </a:p>
+                  </a:txBody>
+                  <a:tcPr/>
+                </a:tc>
+                <a:tc>
+                  <a:txBody>
+                    <a:bodyPr/>
+                    <a:lstStyle/>
+                    <a:p>
+                      <a:r>
+                        <a:rPr dirty="0" lang="en-US"/>
+                        <a:t>Text 11</a:t>
+                      </a:r>
+                    </a:p>
+                  </a:txBody>
+                  <a:tcPr/>
+                </a:tc>
+                <a:tc>
+                  <a:txBody>
+                    <a:bodyPr/>
+                    <a:lstStyle/>
+                    <a:p>
+                      <a:r>
+                        <a:rPr dirty="0" lang="en-US"/>
+                        <a:t>Text 12</a:t>
+                      </a:r>
                     </a:p>
                   </a:txBody>
                   <a:tcPr/>
@@ -3501,6 +3959,65 @@
                   </a:ext>
                 </a:extLst>
               </a:tr>
+              <a:tr h="370840">
+                <a:tc>
+                  <a:txBody>
+                    <a:bodyPr/>
+                    <a:lstStyle/>
+                    <a:p>
+                      <a:r>
+                        <a:rPr dirty="0" lang="en-US"/>
+                        <a:t>Text 13</a:t>
+                      </a:r>
+                    </a:p>
+                  </a:txBody>
+                  <a:tcPr/>
+                </a:tc>
+                <a:tc>
+                  <a:txBody>
+                    <a:bodyPr/>
+                    <a:lstStyle/>
+                    <a:p>
+                      <a:r>
+                        <a:rPr dirty="0" lang="en-US"/>
+                        <a:t>Text 14</a:t>
+                      </a:r>
+                    </a:p>
+                  </a:txBody>
+                  <a:tcPr/>
+                </a:tc>
+                <a:tc>
+                  <a:txBody>
+                    <a:bodyPr/>
+                    <a:lstStyle/>
+                    <a:p>
+                      <a:r>
+                        <a:rPr dirty="0" lang="en-US"/>
+                        <a:t>Text 15</a:t>
+                      </a:r>
+                    </a:p>
+                  </a:txBody>
+                  <a:tcPr/>
+                </a:tc>
+                <a:tc>
+                  <a:txBody>
+                    <a:bodyPr/>
+                    <a:lstStyle/>
+                    <a:p>
+                      <a:r>
+                        <a:rPr dirty="0" lang="en-US"/>
+                        <a:t>Text 16</a:t>
+                      </a:r>
+                    </a:p>
+                  </a:txBody>
+                  <a:tcPr/>
+                </a:tc>
+                <a:extLst>
+                  <a:ext uri="{0D108BD9-81ED-4DB2-BD59-A6C34878D82A}">
+                    <a16:rowId xmlns:a16="http://schemas.microsoft.com/office/drawing/2014/main" val="1995051742"/>
+                  </a:ext>
+                </a:extLst>
+              </a:tr>
             </a:tbl>
           </a:graphicData>
         </a:graphic>
@@ -3508,7 +4025,7 @@
     </p:spTree>
     <p:extLst>
       <p:ext uri="{BB962C8B-B14F-4D97-AF65-F5344CB8AC3E}">
-        <p14:creationId xmlns:p14="http://schemas.microsoft.com/office/powerpoint/2010/main" val="4185553753"/>
+        <p14:creationId xmlns:p14="http://schemas.microsoft.com/office/powerpoint/2010/main" val="1601241158"/>
       </p:ext>
     </p:extLst>
   </p:cSld>

</xml_diff>